<commit_message>
Seasonal Agriculture Performance Analysis-MAJOR PROJECT
</commit_message>
<xml_diff>
--- a/Vidhya_Majee___VOIS_Major_Project_PPT_Seasonal_Agriculture_Performance_Analysis.pptx
+++ b/Vidhya_Majee___VOIS_Major_Project_PPT_Seasonal_Agriculture_Performance_Analysis.pptx
@@ -190,7 +190,7 @@
 <p1510:revInfo xmlns:a="http://schemas.openxmlformats.org/drawingml/2006/main" xmlns:r="http://schemas.openxmlformats.org/officeDocument/2006/relationships" xmlns:p1510="http://schemas.microsoft.com/office/powerpoint/2015/10/main">
   <p1510:revLst>
     <p1510:client id="{32E4DB7F-1028-4FCE-B38E-CEEB6049508C}" v="109" dt="2026-09-04T06:23:28.678"/>
-    <p1510:client id="{EF730085-4CDC-4C53-9EAC-0409C9C577CF}" v="7" dt="2026-09-04T15:31:26.997"/>
+    <p1510:client id="{EF730085-4CDC-4C53-9EAC-0409C9C577CF}" v="12" dt="2026-09-04T17:28:45.093"/>
   </p1510:revLst>
 </p1510:revInfo>
 </file>
@@ -200,7 +200,7 @@
   <pc:docChgLst>
     <pc:chgData name="Vidhya Majee" userId="641a53838c14f1ed" providerId="LiveId" clId="{EF730085-4CDC-4C53-9EAC-0409C9C577CF}"/>
     <pc:docChg chg="undo custSel modSld">
-      <pc:chgData name="Vidhya Majee" userId="641a53838c14f1ed" providerId="LiveId" clId="{EF730085-4CDC-4C53-9EAC-0409C9C577CF}" dt="2026-09-04T15:42:28.926" v="208" actId="14100"/>
+      <pc:chgData name="Vidhya Majee" userId="641a53838c14f1ed" providerId="LiveId" clId="{EF730085-4CDC-4C53-9EAC-0409C9C577CF}" dt="2026-09-04T17:30:07.446" v="270" actId="14100"/>
       <pc:docMkLst>
         <pc:docMk/>
       </pc:docMkLst>
@@ -250,8 +250,8 @@
           </ac:spMkLst>
         </pc:spChg>
       </pc:sldChg>
-      <pc:sldChg chg="addSp modSp mod">
-        <pc:chgData name="Vidhya Majee" userId="641a53838c14f1ed" providerId="LiveId" clId="{EF730085-4CDC-4C53-9EAC-0409C9C577CF}" dt="2026-09-04T15:34:46.457" v="191" actId="14100"/>
+      <pc:sldChg chg="addSp delSp modSp mod">
+        <pc:chgData name="Vidhya Majee" userId="641a53838c14f1ed" providerId="LiveId" clId="{EF730085-4CDC-4C53-9EAC-0409C9C577CF}" dt="2026-09-04T17:24:57.527" v="218" actId="14100"/>
         <pc:sldMkLst>
           <pc:docMk/>
           <pc:sldMk cId="1086225493" sldId="339"/>
@@ -272,16 +272,24 @@
             <ac:spMk id="10" creationId="{B19D8AC7-3787-4ADB-9212-0808F015C2DD}"/>
           </ac:spMkLst>
         </pc:spChg>
-        <pc:picChg chg="add mod">
-          <ac:chgData name="Vidhya Majee" userId="641a53838c14f1ed" providerId="LiveId" clId="{EF730085-4CDC-4C53-9EAC-0409C9C577CF}" dt="2026-09-04T15:27:57.786" v="127" actId="14100"/>
+        <pc:picChg chg="add del mod">
+          <ac:chgData name="Vidhya Majee" userId="641a53838c14f1ed" providerId="LiveId" clId="{EF730085-4CDC-4C53-9EAC-0409C9C577CF}" dt="2026-09-04T17:23:59.560" v="209" actId="21"/>
           <ac:picMkLst>
             <pc:docMk/>
             <pc:sldMk cId="1086225493" sldId="339"/>
             <ac:picMk id="3" creationId="{6A20E020-0DCC-EC0B-745A-E7CAF08DEC57}"/>
           </ac:picMkLst>
         </pc:picChg>
+        <pc:picChg chg="add mod">
+          <ac:chgData name="Vidhya Majee" userId="641a53838c14f1ed" providerId="LiveId" clId="{EF730085-4CDC-4C53-9EAC-0409C9C577CF}" dt="2026-09-04T17:24:57.527" v="218" actId="14100"/>
+          <ac:picMkLst>
+            <pc:docMk/>
+            <pc:sldMk cId="1086225493" sldId="339"/>
+            <ac:picMk id="6" creationId="{2C2A25F1-FA1A-B5DA-0933-B92A3A547E9C}"/>
+          </ac:picMkLst>
+        </pc:picChg>
         <pc:picChg chg="mod">
-          <ac:chgData name="Vidhya Majee" userId="641a53838c14f1ed" providerId="LiveId" clId="{EF730085-4CDC-4C53-9EAC-0409C9C577CF}" dt="2026-09-04T15:28:02.365" v="128" actId="14100"/>
+          <ac:chgData name="Vidhya Majee" userId="641a53838c14f1ed" providerId="LiveId" clId="{EF730085-4CDC-4C53-9EAC-0409C9C577CF}" dt="2026-09-04T17:24:48.013" v="217" actId="14100"/>
           <ac:picMkLst>
             <pc:docMk/>
             <pc:sldMk cId="1086225493" sldId="339"/>
@@ -289,8 +297,8 @@
           </ac:picMkLst>
         </pc:picChg>
       </pc:sldChg>
-      <pc:sldChg chg="addSp modSp mod">
-        <pc:chgData name="Vidhya Majee" userId="641a53838c14f1ed" providerId="LiveId" clId="{EF730085-4CDC-4C53-9EAC-0409C9C577CF}" dt="2026-09-04T15:39:17.921" v="201" actId="14100"/>
+      <pc:sldChg chg="addSp delSp modSp mod">
+        <pc:chgData name="Vidhya Majee" userId="641a53838c14f1ed" providerId="LiveId" clId="{EF730085-4CDC-4C53-9EAC-0409C9C577CF}" dt="2026-09-04T17:26:15.171" v="232" actId="14100"/>
         <pc:sldMkLst>
           <pc:docMk/>
           <pc:sldMk cId="3849627828" sldId="340"/>
@@ -311,16 +319,24 @@
             <ac:spMk id="10" creationId="{3A64DB11-806F-1A4C-E0D5-D745D29CED50}"/>
           </ac:spMkLst>
         </pc:spChg>
-        <pc:picChg chg="add mod">
-          <ac:chgData name="Vidhya Majee" userId="641a53838c14f1ed" providerId="LiveId" clId="{EF730085-4CDC-4C53-9EAC-0409C9C577CF}" dt="2026-09-04T15:39:17.921" v="201" actId="14100"/>
+        <pc:picChg chg="add del mod">
+          <ac:chgData name="Vidhya Majee" userId="641a53838c14f1ed" providerId="LiveId" clId="{EF730085-4CDC-4C53-9EAC-0409C9C577CF}" dt="2026-09-04T17:25:06.267" v="219" actId="21"/>
           <ac:picMkLst>
             <pc:docMk/>
             <pc:sldMk cId="3849627828" sldId="340"/>
             <ac:picMk id="3" creationId="{05A88067-6EAB-0184-9A59-326B2A156DC3}"/>
           </ac:picMkLst>
         </pc:picChg>
+        <pc:picChg chg="add mod">
+          <ac:chgData name="Vidhya Majee" userId="641a53838c14f1ed" providerId="LiveId" clId="{EF730085-4CDC-4C53-9EAC-0409C9C577CF}" dt="2026-09-04T17:26:15.171" v="232" actId="14100"/>
+          <ac:picMkLst>
+            <pc:docMk/>
+            <pc:sldMk cId="3849627828" sldId="340"/>
+            <ac:picMk id="6" creationId="{2F30A252-44E9-8505-87BC-C34142D0730E}"/>
+          </ac:picMkLst>
+        </pc:picChg>
         <pc:picChg chg="mod">
-          <ac:chgData name="Vidhya Majee" userId="641a53838c14f1ed" providerId="LiveId" clId="{EF730085-4CDC-4C53-9EAC-0409C9C577CF}" dt="2026-09-04T15:39:05.287" v="199" actId="14100"/>
+          <ac:chgData name="Vidhya Majee" userId="641a53838c14f1ed" providerId="LiveId" clId="{EF730085-4CDC-4C53-9EAC-0409C9C577CF}" dt="2026-09-04T17:26:12.220" v="231" actId="14100"/>
           <ac:picMkLst>
             <pc:docMk/>
             <pc:sldMk cId="3849627828" sldId="340"/>
@@ -343,8 +359,8 @@
           </ac:spMkLst>
         </pc:spChg>
       </pc:sldChg>
-      <pc:sldChg chg="addSp modSp mod">
-        <pc:chgData name="Vidhya Majee" userId="641a53838c14f1ed" providerId="LiveId" clId="{EF730085-4CDC-4C53-9EAC-0409C9C577CF}" dt="2026-09-04T15:35:11.472" v="194" actId="14100"/>
+      <pc:sldChg chg="addSp delSp modSp mod">
+        <pc:chgData name="Vidhya Majee" userId="641a53838c14f1ed" providerId="LiveId" clId="{EF730085-4CDC-4C53-9EAC-0409C9C577CF}" dt="2026-09-04T17:27:12.316" v="239" actId="14100"/>
         <pc:sldMkLst>
           <pc:docMk/>
           <pc:sldMk cId="1698901770" sldId="344"/>
@@ -365,12 +381,20 @@
             <ac:spMk id="10" creationId="{B6E3B1C7-6A8B-23EE-6251-DC1067C6ADE9}"/>
           </ac:spMkLst>
         </pc:spChg>
-        <pc:picChg chg="add mod">
-          <ac:chgData name="Vidhya Majee" userId="641a53838c14f1ed" providerId="LiveId" clId="{EF730085-4CDC-4C53-9EAC-0409C9C577CF}" dt="2026-09-04T15:28:43.377" v="133" actId="14100"/>
+        <pc:picChg chg="add del mod">
+          <ac:chgData name="Vidhya Majee" userId="641a53838c14f1ed" providerId="LiveId" clId="{EF730085-4CDC-4C53-9EAC-0409C9C577CF}" dt="2026-09-04T17:26:33.831" v="233" actId="21"/>
           <ac:picMkLst>
             <pc:docMk/>
             <pc:sldMk cId="1698901770" sldId="344"/>
             <ac:picMk id="3" creationId="{10190294-024A-3D73-2FE2-7FAB215FA91C}"/>
+          </ac:picMkLst>
+        </pc:picChg>
+        <pc:picChg chg="add mod">
+          <ac:chgData name="Vidhya Majee" userId="641a53838c14f1ed" providerId="LiveId" clId="{EF730085-4CDC-4C53-9EAC-0409C9C577CF}" dt="2026-09-04T17:27:12.316" v="239" actId="14100"/>
+          <ac:picMkLst>
+            <pc:docMk/>
+            <pc:sldMk cId="1698901770" sldId="344"/>
+            <ac:picMk id="6" creationId="{51FDB9BA-71B1-6032-392F-E88769C65372}"/>
           </ac:picMkLst>
         </pc:picChg>
         <pc:picChg chg="mod">
@@ -382,8 +406,8 @@
           </ac:picMkLst>
         </pc:picChg>
       </pc:sldChg>
-      <pc:sldChg chg="addSp modSp mod">
-        <pc:chgData name="Vidhya Majee" userId="641a53838c14f1ed" providerId="LiveId" clId="{EF730085-4CDC-4C53-9EAC-0409C9C577CF}" dt="2026-09-04T15:41:48.188" v="206" actId="14100"/>
+      <pc:sldChg chg="addSp delSp modSp mod">
+        <pc:chgData name="Vidhya Majee" userId="641a53838c14f1ed" providerId="LiveId" clId="{EF730085-4CDC-4C53-9EAC-0409C9C577CF}" dt="2026-09-04T17:28:21.648" v="253" actId="14100"/>
         <pc:sldMkLst>
           <pc:docMk/>
           <pc:sldMk cId="1903979828" sldId="345"/>
@@ -404,16 +428,24 @@
             <ac:spMk id="10" creationId="{2B7B89A1-9444-8322-CADC-42D31D698FA8}"/>
           </ac:spMkLst>
         </pc:spChg>
-        <pc:picChg chg="add mod">
-          <ac:chgData name="Vidhya Majee" userId="641a53838c14f1ed" providerId="LiveId" clId="{EF730085-4CDC-4C53-9EAC-0409C9C577CF}" dt="2026-09-04T15:30:33.091" v="153" actId="14100"/>
+        <pc:picChg chg="add del mod">
+          <ac:chgData name="Vidhya Majee" userId="641a53838c14f1ed" providerId="LiveId" clId="{EF730085-4CDC-4C53-9EAC-0409C9C577CF}" dt="2026-09-04T17:27:29.479" v="241" actId="21"/>
           <ac:picMkLst>
             <pc:docMk/>
             <pc:sldMk cId="1903979828" sldId="345"/>
             <ac:picMk id="3" creationId="{5BBABFA1-2CA4-7131-AAA2-CA9FC72AB107}"/>
           </ac:picMkLst>
         </pc:picChg>
+        <pc:picChg chg="add mod">
+          <ac:chgData name="Vidhya Majee" userId="641a53838c14f1ed" providerId="LiveId" clId="{EF730085-4CDC-4C53-9EAC-0409C9C577CF}" dt="2026-09-04T17:28:21.648" v="253" actId="14100"/>
+          <ac:picMkLst>
+            <pc:docMk/>
+            <pc:sldMk cId="1903979828" sldId="345"/>
+            <ac:picMk id="6" creationId="{2B2FE8B7-133B-379D-A522-7692D12DEBEC}"/>
+          </ac:picMkLst>
+        </pc:picChg>
         <pc:picChg chg="mod">
-          <ac:chgData name="Vidhya Majee" userId="641a53838c14f1ed" providerId="LiveId" clId="{EF730085-4CDC-4C53-9EAC-0409C9C577CF}" dt="2026-09-04T15:41:48.188" v="206" actId="14100"/>
+          <ac:chgData name="Vidhya Majee" userId="641a53838c14f1ed" providerId="LiveId" clId="{EF730085-4CDC-4C53-9EAC-0409C9C577CF}" dt="2026-09-04T17:28:08.080" v="251" actId="14100"/>
           <ac:picMkLst>
             <pc:docMk/>
             <pc:sldMk cId="1903979828" sldId="345"/>
@@ -421,8 +453,8 @@
           </ac:picMkLst>
         </pc:picChg>
       </pc:sldChg>
-      <pc:sldChg chg="addSp modSp mod">
-        <pc:chgData name="Vidhya Majee" userId="641a53838c14f1ed" providerId="LiveId" clId="{EF730085-4CDC-4C53-9EAC-0409C9C577CF}" dt="2026-09-04T15:33:55.460" v="190" actId="14100"/>
+      <pc:sldChg chg="addSp delSp modSp mod">
+        <pc:chgData name="Vidhya Majee" userId="641a53838c14f1ed" providerId="LiveId" clId="{EF730085-4CDC-4C53-9EAC-0409C9C577CF}" dt="2026-09-04T17:30:07.446" v="270" actId="14100"/>
         <pc:sldMkLst>
           <pc:docMk/>
           <pc:sldMk cId="1421522261" sldId="346"/>
@@ -443,12 +475,20 @@
             <ac:spMk id="10" creationId="{F85C769B-425A-FE3B-E47A-3B747985DC52}"/>
           </ac:spMkLst>
         </pc:spChg>
-        <pc:picChg chg="add mod">
-          <ac:chgData name="Vidhya Majee" userId="641a53838c14f1ed" providerId="LiveId" clId="{EF730085-4CDC-4C53-9EAC-0409C9C577CF}" dt="2026-09-04T15:33:41.577" v="189" actId="14100"/>
+        <pc:picChg chg="add del mod">
+          <ac:chgData name="Vidhya Majee" userId="641a53838c14f1ed" providerId="LiveId" clId="{EF730085-4CDC-4C53-9EAC-0409C9C577CF}" dt="2026-09-04T17:28:31.429" v="254" actId="21"/>
           <ac:picMkLst>
             <pc:docMk/>
             <pc:sldMk cId="1421522261" sldId="346"/>
             <ac:picMk id="3" creationId="{B631DD34-0E3C-2138-50C5-4F6D0FE55733}"/>
+          </ac:picMkLst>
+        </pc:picChg>
+        <pc:picChg chg="add mod">
+          <ac:chgData name="Vidhya Majee" userId="641a53838c14f1ed" providerId="LiveId" clId="{EF730085-4CDC-4C53-9EAC-0409C9C577CF}" dt="2026-09-04T17:30:07.446" v="270" actId="14100"/>
+          <ac:picMkLst>
+            <pc:docMk/>
+            <pc:sldMk cId="1421522261" sldId="346"/>
+            <ac:picMk id="6" creationId="{CD471A0B-5B5B-36F7-9E86-233E06345336}"/>
           </ac:picMkLst>
         </pc:picChg>
         <pc:picChg chg="mod">
@@ -12046,10 +12086,10 @@
       </p:pic>
       <p:pic>
         <p:nvPicPr>
-          <p:cNvPr id="3" name="Picture 2">
+          <p:cNvPr id="6" name="Picture 5">
             <a:extLst>
               <a:ext uri="{FF2B5EF4-FFF2-40B4-BE49-F238E27FC236}">
-                <a16:creationId xmlns:a16="http://schemas.microsoft.com/office/drawing/2014/main" id="{B631DD34-0E3C-2138-50C5-4F6D0FE55733}"/>
+                <a16:creationId xmlns:a16="http://schemas.microsoft.com/office/drawing/2014/main" id="{CD471A0B-5B5B-36F7-9E86-233E06345336}"/>
               </a:ext>
             </a:extLst>
           </p:cNvPr>
@@ -12066,8 +12106,8 @@
         </p:blipFill>
         <p:spPr>
           <a:xfrm>
-            <a:off x="8370407" y="1353670"/>
-            <a:ext cx="3821592" cy="5504329"/>
+            <a:off x="8337176" y="2447365"/>
+            <a:ext cx="3832729" cy="4303060"/>
           </a:xfrm>
           <a:prstGeom prst="rect">
             <a:avLst/>
@@ -20312,7 +20352,7 @@
         <p:spPr>
           <a:xfrm>
             <a:off x="1" y="1275371"/>
-            <a:ext cx="9246636" cy="5489323"/>
+            <a:ext cx="9144262" cy="5489323"/>
           </a:xfrm>
           <a:prstGeom prst="rect">
             <a:avLst/>
@@ -20321,10 +20361,10 @@
       </p:pic>
       <p:pic>
         <p:nvPicPr>
-          <p:cNvPr id="3" name="Picture 2">
+          <p:cNvPr id="6" name="Picture 5">
             <a:extLst>
               <a:ext uri="{FF2B5EF4-FFF2-40B4-BE49-F238E27FC236}">
-                <a16:creationId xmlns:a16="http://schemas.microsoft.com/office/drawing/2014/main" id="{6A20E020-0DCC-EC0B-745A-E7CAF08DEC57}"/>
+                <a16:creationId xmlns:a16="http://schemas.microsoft.com/office/drawing/2014/main" id="{2C2A25F1-FA1A-B5DA-0933-B92A3A547E9C}"/>
               </a:ext>
             </a:extLst>
           </p:cNvPr>
@@ -20341,8 +20381,8 @@
         </p:blipFill>
         <p:spPr>
           <a:xfrm>
-            <a:off x="9035774" y="866158"/>
-            <a:ext cx="3190383" cy="5991842"/>
+            <a:off x="9144263" y="1138519"/>
+            <a:ext cx="3047736" cy="5719482"/>
           </a:xfrm>
           <a:prstGeom prst="rect">
             <a:avLst/>
@@ -21474,7 +21514,7 @@
         <p:spPr>
           <a:xfrm>
             <a:off x="1" y="1492898"/>
-            <a:ext cx="8928846" cy="5172062"/>
+            <a:ext cx="8695764" cy="5172062"/>
           </a:xfrm>
           <a:prstGeom prst="rect">
             <a:avLst/>
@@ -21483,10 +21523,10 @@
       </p:pic>
       <p:pic>
         <p:nvPicPr>
-          <p:cNvPr id="3" name="Picture 2">
+          <p:cNvPr id="6" name="Picture 5">
             <a:extLst>
               <a:ext uri="{FF2B5EF4-FFF2-40B4-BE49-F238E27FC236}">
-                <a16:creationId xmlns:a16="http://schemas.microsoft.com/office/drawing/2014/main" id="{05A88067-6EAB-0184-9A59-326B2A156DC3}"/>
+                <a16:creationId xmlns:a16="http://schemas.microsoft.com/office/drawing/2014/main" id="{2F30A252-44E9-8505-87BC-C34142D0730E}"/>
               </a:ext>
             </a:extLst>
           </p:cNvPr>
@@ -21503,8 +21543,8 @@
         </p:blipFill>
         <p:spPr>
           <a:xfrm>
-            <a:off x="8928847" y="1275371"/>
-            <a:ext cx="3263153" cy="5553684"/>
+            <a:off x="8695765" y="1492898"/>
+            <a:ext cx="3496234" cy="5293069"/>
           </a:xfrm>
           <a:prstGeom prst="rect">
             <a:avLst/>
@@ -22645,10 +22685,10 @@
       </p:pic>
       <p:pic>
         <p:nvPicPr>
-          <p:cNvPr id="3" name="Picture 2">
+          <p:cNvPr id="6" name="Picture 5">
             <a:extLst>
               <a:ext uri="{FF2B5EF4-FFF2-40B4-BE49-F238E27FC236}">
-                <a16:creationId xmlns:a16="http://schemas.microsoft.com/office/drawing/2014/main" id="{10190294-024A-3D73-2FE2-7FAB215FA91C}"/>
+                <a16:creationId xmlns:a16="http://schemas.microsoft.com/office/drawing/2014/main" id="{51FDB9BA-71B1-6032-392F-E88769C65372}"/>
               </a:ext>
             </a:extLst>
           </p:cNvPr>
@@ -22665,8 +22705,8 @@
         </p:blipFill>
         <p:spPr>
           <a:xfrm>
-            <a:off x="8848441" y="999864"/>
-            <a:ext cx="3343283" cy="5858136"/>
+            <a:off x="8848441" y="1859502"/>
+            <a:ext cx="3343283" cy="4805458"/>
           </a:xfrm>
           <a:prstGeom prst="rect">
             <a:avLst/>
@@ -23799,8 +23839,8 @@
         </p:blipFill>
         <p:spPr>
           <a:xfrm>
-            <a:off x="-1" y="1694330"/>
-            <a:ext cx="8527459" cy="5091951"/>
+            <a:off x="0" y="1694330"/>
+            <a:ext cx="8808098" cy="5091951"/>
           </a:xfrm>
           <a:prstGeom prst="rect">
             <a:avLst/>
@@ -23809,10 +23849,10 @@
       </p:pic>
       <p:pic>
         <p:nvPicPr>
-          <p:cNvPr id="3" name="Picture 2">
+          <p:cNvPr id="6" name="Picture 5">
             <a:extLst>
               <a:ext uri="{FF2B5EF4-FFF2-40B4-BE49-F238E27FC236}">
-                <a16:creationId xmlns:a16="http://schemas.microsoft.com/office/drawing/2014/main" id="{5BBABFA1-2CA4-7131-AAA2-CA9FC72AB107}"/>
+                <a16:creationId xmlns:a16="http://schemas.microsoft.com/office/drawing/2014/main" id="{2B2FE8B7-133B-379D-A522-7692D12DEBEC}"/>
               </a:ext>
             </a:extLst>
           </p:cNvPr>
@@ -23829,8 +23869,8 @@
         </p:blipFill>
         <p:spPr>
           <a:xfrm>
-            <a:off x="8552329" y="1380565"/>
-            <a:ext cx="3639670" cy="5405716"/>
+            <a:off x="7511142" y="3429001"/>
+            <a:ext cx="4680857" cy="3357280"/>
           </a:xfrm>
           <a:prstGeom prst="rect">
             <a:avLst/>
@@ -25377,21 +25417,21 @@
 </file>
 
 <file path=customXml/item2.xml><?xml version="1.0" encoding="utf-8"?>
+<?mso-contentType ?>
+<FormTemplates xmlns="http://schemas.microsoft.com/sharepoint/v3/contenttype/forms">
+  <Display>DocumentLibraryForm</Display>
+  <Edit>DocumentLibraryForm</Edit>
+  <New>DocumentLibraryForm</New>
+</FormTemplates>
+</file>
+
+<file path=customXml/item3.xml><?xml version="1.0" encoding="utf-8"?>
 <p:properties xmlns:p="http://schemas.microsoft.com/office/2006/metadata/properties" xmlns:xsi="http://www.w3.org/2001/XMLSchema-instance" xmlns:pc="http://schemas.microsoft.com/office/infopath/2007/PartnerControls">
   <documentManagement>
     <Status xmlns="71af3243-3dd4-4a8d-8c0d-dd76da1f02a5">Not started</Status>
     <MediaServiceKeyPoints xmlns="71af3243-3dd4-4a8d-8c0d-dd76da1f02a5" xsi:nil="true"/>
   </documentManagement>
 </p:properties>
-</file>
-
-<file path=customXml/item3.xml><?xml version="1.0" encoding="utf-8"?>
-<?mso-contentType ?>
-<FormTemplates xmlns="http://schemas.microsoft.com/sharepoint/v3/contenttype/forms">
-  <Display>DocumentLibraryForm</Display>
-  <Edit>DocumentLibraryForm</Edit>
-  <New>DocumentLibraryForm</New>
-</FormTemplates>
 </file>
 
 <file path=customXml/itemProps1.xml><?xml version="1.0" encoding="utf-8"?>
@@ -25414,6 +25454,14 @@
 </file>
 
 <file path=customXml/itemProps2.xml><?xml version="1.0" encoding="utf-8"?>
+<ds:datastoreItem xmlns:ds="http://schemas.openxmlformats.org/officeDocument/2006/customXml" ds:itemID="{05D99ABA-76CE-4A8E-B5F0-C051B96628DE}">
+  <ds:schemaRefs>
+    <ds:schemaRef ds:uri="http://schemas.microsoft.com/sharepoint/v3/contenttype/forms"/>
+  </ds:schemaRefs>
+</ds:datastoreItem>
+</file>
+
+<file path=customXml/itemProps3.xml><?xml version="1.0" encoding="utf-8"?>
 <ds:datastoreItem xmlns:ds="http://schemas.openxmlformats.org/officeDocument/2006/customXml" ds:itemID="{4DEA9014-ED64-4558-B1E1-D03F0EE32BEB}">
   <ds:schemaRefs>
     <ds:schemaRef ds:uri="http://schemas.microsoft.com/office/2006/metadata/properties"/>
@@ -25421,12 +25469,4 @@
     <ds:schemaRef ds:uri="71af3243-3dd4-4a8d-8c0d-dd76da1f02a5"/>
   </ds:schemaRefs>
 </ds:datastoreItem>
-</file>
-
-<file path=customXml/itemProps3.xml><?xml version="1.0" encoding="utf-8"?>
-<ds:datastoreItem xmlns:ds="http://schemas.openxmlformats.org/officeDocument/2006/customXml" ds:itemID="{05D99ABA-76CE-4A8E-B5F0-C051B96628DE}">
-  <ds:schemaRefs>
-    <ds:schemaRef ds:uri="http://schemas.microsoft.com/sharepoint/v3/contenttype/forms"/>
-  </ds:schemaRefs>
-</ds:datastoreItem>
 </file>
</xml_diff>